<commit_message>
Papel Misionero: deck sin menciones a Estudio 83
Co-Authored-By: Claude Opus 5.5 <noreply@anthropic.com>
Claude-Session: https://claude.ai/code/session_01KUhywj7pPw1dWRbd6BgkDY
</commit_message>
<xml_diff>
--- a/papel-misionero/marcas-finalistas.pptx
+++ b/papel-misionero/marcas-finalistas.pptx
@@ -124,12 +124,12 @@
   <p:extLst>
     <p:ext uri="{521415D9-36F7-43E2-AB2F-B90AF26B5E84}">
       <p14:sectionLst xmlns:p14="http://schemas.microsoft.com/office/powerpoint/2010/main">
-        <p14:section name="Portada" id="{4f129cb4-890a-919b-5585-a171b5330054}">
+        <p14:section name="Portada" id="{03651499-aad9-2b07-cb4b-92ca5846e7cd}">
           <p14:sldIdLst>
             <p14:sldId id="256"/>
           </p14:sldIdLst>
         </p14:section>
-        <p14:section name="La P" id="{5ff21ae8-2fff-9d22-d75a-0219831a0531}">
+        <p14:section name="La P" id="{f00f7a12-5d90-3596-57a3-5e7dfeb4c86d}">
           <p14:sldIdLst>
             <p14:sldId id="257"/>
             <p14:sldId id="258"/>
@@ -138,7 +138,7 @@
             <p14:sldId id="261"/>
           </p14:sldIdLst>
         </p14:section>
-        <p14:section name="Sellos y contenedores" id="{6f1c2f25-1d2e-f1fd-d128-09e82cf8f45c}">
+        <p14:section name="Sellos y contenedores" id="{144e3aa2-dd7f-2802-533d-713f8568edb9}">
           <p14:sldIdLst>
             <p14:sldId id="262"/>
             <p14:sldId id="263"/>
@@ -148,7 +148,7 @@
             <p14:sldId id="267"/>
           </p14:sldIdLst>
         </p14:section>
-        <p14:section name="Árbol solo" id="{3350ea86-6c26-bd1c-5312-49a5d7cebee9}">
+        <p14:section name="Árbol solo" id="{f3cfc87d-b773-172c-58cc-71250214605a}">
           <p14:sldIdLst>
             <p14:sldId id="268"/>
             <p14:sldId id="269"/>
@@ -2232,42 +2232,6 @@
           </a:p>
         </p:txBody>
       </p:sp>
-      <p:sp>
-        <p:nvSpPr>
-          <p:cNvPr id="4" name="Text 0"/>
-          <p:cNvSpPr/>
-          <p:nvPr/>
-        </p:nvSpPr>
-        <p:spPr>
-          <a:xfrm>
-            <a:off x="731520" y="6035040"/>
-            <a:ext cx="7315200" cy="365760"/>
-          </a:xfrm>
-          <a:prstGeom prst="rect">
-            <a:avLst/>
-          </a:prstGeom>
-          <a:noFill/>
-          <a:ln/>
-        </p:spPr>
-        <p:txBody>
-          <a:bodyPr wrap="square" lIns="0" tIns="0" rIns="0" bIns="0" rtlCol="0" anchor="ctr"/>
-          <a:lstStyle/>
-          <a:p>
-            <a:pPr indent="0" marL="0">
-              <a:buNone/>
-            </a:pPr>
-            <a:r>
-              <a:rPr lang="en-US" sz="1100" spc="400" kern="0" dirty="0">
-                <a:solidFill>
-                  <a:schemeClr val="accent5"/>
-                </a:solidFill>
-              </a:rPr>
-              <a:t>ESTUDIO 83 · PARA CARTOCOR</a:t>
-            </a:r>
-            <a:endParaRPr lang="en-US" sz="1100" dirty="0"/>
-          </a:p>
-        </p:txBody>
-      </p:sp>
     </p:spTree>
   </p:cSld>
   <p:clrMapOvr>
@@ -2557,7 +2521,7 @@
                   <a:schemeClr val="accent6"/>
                 </a:solidFill>
               </a:rPr>
-              <a:t>ESTUDIO 83 · PAPEL MISIONERO</a:t>
+              <a:t>PAPEL MISIONERO</a:t>
             </a:r>
             <a:endParaRPr lang="en-US" sz="1000" dirty="0"/>
           </a:p>

</xml_diff>

<commit_message>
Papel Misionero: sección Sistema en el deck (paleta, tipografía, reglas y pruebas de color)
Co-Authored-By: Claude Opus 5.5 <noreply@anthropic.com>
Claude-Session: https://claude.ai/code/session_01KUhywj7pPw1dWRbd6BgkDY
</commit_message>
<xml_diff>
--- a/papel-misionero/marcas-finalistas.pptx
+++ b/papel-misionero/marcas-finalistas.pptx
@@ -26,9 +26,12 @@
     <p:sldId id="274" r:id="rId20"/>
     <p:sldId id="275" r:id="rId21"/>
     <p:sldId id="276" r:id="rId22"/>
+    <p:sldId id="277" r:id="rId23"/>
+    <p:sldId id="278" r:id="rId24"/>
+    <p:sldId id="279" r:id="rId25"/>
   </p:sldIdLst>
   <p:notesMasterIdLst>
-    <p:notesMasterId r:id="rId23"/>
+    <p:notesMasterId r:id="rId26"/>
   </p:notesMasterIdLst>
   <p:sldSz cx="12192000" cy="6858000"/>
   <p:notesSz cx="6858000" cy="12192000"/>
@@ -127,19 +130,19 @@
   <p:extLst>
     <p:ext uri="{521415D9-36F7-43E2-AB2F-B90AF26B5E84}">
       <p14:sectionLst xmlns:p14="http://schemas.microsoft.com/office/powerpoint/2010/main">
-        <p14:section name="Portada" id="{6e48cb91-f32d-3918-b54c-7c712739917f}">
+        <p14:section name="Portada" id="{ee9fdf11-12b6-5cd7-80da-b125bfada7dc}">
           <p14:sldIdLst>
             <p14:sldId id="256"/>
           </p14:sldIdLst>
         </p14:section>
-        <p14:section name="Benchmark" id="{f1e0886a-009c-8f7d-d204-0093a61b66ac}">
+        <p14:section name="Benchmark" id="{227b8bb6-4aab-7a76-6c70-05a20218d4fc}">
           <p14:sldIdLst>
             <p14:sldId id="257"/>
             <p14:sldId id="258"/>
             <p14:sldId id="259"/>
           </p14:sldIdLst>
         </p14:section>
-        <p14:section name="La P" id="{bf965b05-fd78-98e7-4974-47772c8d1466}">
+        <p14:section name="La P" id="{7ba5f088-28af-7cec-3f59-d189f22c7999}">
           <p14:sldIdLst>
             <p14:sldId id="260"/>
             <p14:sldId id="261"/>
@@ -148,7 +151,7 @@
             <p14:sldId id="264"/>
           </p14:sldIdLst>
         </p14:section>
-        <p14:section name="Sellos y contenedores" id="{d5c36879-0084-dcd1-f01d-f31d1d863340}">
+        <p14:section name="Sellos y contenedores" id="{9f737b1c-962f-8b1f-274b-6e66baebe353}">
           <p14:sldIdLst>
             <p14:sldId id="265"/>
             <p14:sldId id="266"/>
@@ -158,7 +161,7 @@
             <p14:sldId id="270"/>
           </p14:sldIdLst>
         </p14:section>
-        <p14:section name="Árbol solo" id="{67668bb5-d2be-53e7-b8ef-eb3cb6e6c991}">
+        <p14:section name="Árbol solo" id="{9b4072e4-3814-f0d6-d2b0-fc2b652eebed}">
           <p14:sldIdLst>
             <p14:sldId id="271"/>
             <p14:sldId id="272"/>
@@ -166,6 +169,13 @@
             <p14:sldId id="274"/>
             <p14:sldId id="275"/>
             <p14:sldId id="276"/>
+          </p14:sldIdLst>
+        </p14:section>
+        <p14:section name="Sistema" id="{5a554a84-bc48-efde-070d-d88b1805e952}">
+          <p14:sldIdLst>
+            <p14:sldId id="277"/>
+            <p14:sldId id="278"/>
+            <p14:sldId id="279"/>
           </p14:sldIdLst>
         </p14:section>
       </p14:sectionLst>
@@ -1740,6 +1750,270 @@
             <a:fld id="{F7021451-1387-4CA6-816F-3879F97B5CBC}" type="slidenum">
               <a:rPr lang="en-US"/>
               <a:t>21</a:t>
+            </a:fld>
+            <a:endParaRPr lang="en-US"/>
+          </a:p>
+        </p:txBody>
+      </p:sp>
+    </p:spTree>
+    <p:extLst>
+      <p:ext uri="{BB962C8B-B14F-4D97-AF65-F5344CB8AC3E}">
+        <p14:creationId xmlns:p14="http://schemas.microsoft.com/office/powerpoint/2010/main" val="1024086991"/>
+      </p:ext>
+    </p:extLst>
+  </p:cSld>
+  <p:clrMapOvr>
+    <a:masterClrMapping/>
+  </p:clrMapOvr>
+</p:notes>
+</file>
+
+<file path=ppt/notesSlides/notesSlide22.xml><?xml version="1.0" encoding="utf-8"?>
+<p:notes xmlns:a="http://schemas.openxmlformats.org/drawingml/2006/main" xmlns:r="http://schemas.openxmlformats.org/officeDocument/2006/relationships" xmlns:p="http://schemas.openxmlformats.org/presentationml/2006/main">
+  <p:cSld>
+    <p:spTree>
+      <p:nvGrpSpPr>
+        <p:cNvPr id="1" name=""/>
+        <p:cNvGrpSpPr/>
+        <p:nvPr/>
+      </p:nvGrpSpPr>
+      <p:grpSpPr>
+        <a:xfrm>
+          <a:off x="0" y="0"/>
+          <a:ext cx="0" cy="0"/>
+          <a:chOff x="0" y="0"/>
+          <a:chExt cx="0" cy="0"/>
+        </a:xfrm>
+      </p:grpSpPr>
+      <p:sp>
+        <p:nvSpPr>
+          <p:cNvPr id="2" name="Slide Image Placeholder 1"/>
+          <p:cNvSpPr>
+            <a:spLocks noGrp="1" noRot="1" noChangeAspect="1"/>
+          </p:cNvSpPr>
+          <p:nvPr>
+            <p:ph type="sldImg"/>
+          </p:nvPr>
+        </p:nvSpPr>
+        <p:spPr/>
+      </p:sp>
+      <p:sp>
+        <p:nvSpPr>
+          <p:cNvPr id="3" name="Notes Placeholder 2"/>
+          <p:cNvSpPr>
+            <a:spLocks noGrp="1"/>
+          </p:cNvSpPr>
+          <p:nvPr>
+            <p:ph type="body" idx="1"/>
+          </p:nvPr>
+        </p:nvSpPr>
+        <p:spPr/>
+        <p:txBody>
+          <a:bodyPr/>
+          <a:lstStyle/>
+          <a:p>
+            <a:r>
+              <a:rPr lang="en-US" dirty="0"/>
+              <a:t/>
+            </a:r>
+            <a:endParaRPr lang="en-US" dirty="0"/>
+          </a:p>
+        </p:txBody>
+      </p:sp>
+      <p:sp>
+        <p:nvSpPr>
+          <p:cNvPr id="4" name="Slide Number Placeholder 3"/>
+          <p:cNvSpPr>
+            <a:spLocks noGrp="1"/>
+          </p:cNvSpPr>
+          <p:nvPr>
+            <p:ph type="sldNum" sz="quarter" idx="10"/>
+          </p:nvPr>
+        </p:nvSpPr>
+        <p:spPr/>
+        <p:txBody>
+          <a:bodyPr/>
+          <a:lstStyle/>
+          <a:p>
+            <a:fld id="{F7021451-1387-4CA6-816F-3879F97B5CBC}" type="slidenum">
+              <a:rPr lang="en-US"/>
+              <a:t>22</a:t>
+            </a:fld>
+            <a:endParaRPr lang="en-US"/>
+          </a:p>
+        </p:txBody>
+      </p:sp>
+    </p:spTree>
+    <p:extLst>
+      <p:ext uri="{BB962C8B-B14F-4D97-AF65-F5344CB8AC3E}">
+        <p14:creationId xmlns:p14="http://schemas.microsoft.com/office/powerpoint/2010/main" val="1024086991"/>
+      </p:ext>
+    </p:extLst>
+  </p:cSld>
+  <p:clrMapOvr>
+    <a:masterClrMapping/>
+  </p:clrMapOvr>
+</p:notes>
+</file>
+
+<file path=ppt/notesSlides/notesSlide23.xml><?xml version="1.0" encoding="utf-8"?>
+<p:notes xmlns:a="http://schemas.openxmlformats.org/drawingml/2006/main" xmlns:r="http://schemas.openxmlformats.org/officeDocument/2006/relationships" xmlns:p="http://schemas.openxmlformats.org/presentationml/2006/main">
+  <p:cSld>
+    <p:spTree>
+      <p:nvGrpSpPr>
+        <p:cNvPr id="1" name=""/>
+        <p:cNvGrpSpPr/>
+        <p:nvPr/>
+      </p:nvGrpSpPr>
+      <p:grpSpPr>
+        <a:xfrm>
+          <a:off x="0" y="0"/>
+          <a:ext cx="0" cy="0"/>
+          <a:chOff x="0" y="0"/>
+          <a:chExt cx="0" cy="0"/>
+        </a:xfrm>
+      </p:grpSpPr>
+      <p:sp>
+        <p:nvSpPr>
+          <p:cNvPr id="2" name="Slide Image Placeholder 1"/>
+          <p:cNvSpPr>
+            <a:spLocks noGrp="1" noRot="1" noChangeAspect="1"/>
+          </p:cNvSpPr>
+          <p:nvPr>
+            <p:ph type="sldImg"/>
+          </p:nvPr>
+        </p:nvSpPr>
+        <p:spPr/>
+      </p:sp>
+      <p:sp>
+        <p:nvSpPr>
+          <p:cNvPr id="3" name="Notes Placeholder 2"/>
+          <p:cNvSpPr>
+            <a:spLocks noGrp="1"/>
+          </p:cNvSpPr>
+          <p:nvPr>
+            <p:ph type="body" idx="1"/>
+          </p:nvPr>
+        </p:nvSpPr>
+        <p:spPr/>
+        <p:txBody>
+          <a:bodyPr/>
+          <a:lstStyle/>
+          <a:p>
+            <a:r>
+              <a:rPr lang="en-US" dirty="0"/>
+              <a:t/>
+            </a:r>
+            <a:endParaRPr lang="en-US" dirty="0"/>
+          </a:p>
+        </p:txBody>
+      </p:sp>
+      <p:sp>
+        <p:nvSpPr>
+          <p:cNvPr id="4" name="Slide Number Placeholder 3"/>
+          <p:cNvSpPr>
+            <a:spLocks noGrp="1"/>
+          </p:cNvSpPr>
+          <p:nvPr>
+            <p:ph type="sldNum" sz="quarter" idx="10"/>
+          </p:nvPr>
+        </p:nvSpPr>
+        <p:spPr/>
+        <p:txBody>
+          <a:bodyPr/>
+          <a:lstStyle/>
+          <a:p>
+            <a:fld id="{F7021451-1387-4CA6-816F-3879F97B5CBC}" type="slidenum">
+              <a:rPr lang="en-US"/>
+              <a:t>23</a:t>
+            </a:fld>
+            <a:endParaRPr lang="en-US"/>
+          </a:p>
+        </p:txBody>
+      </p:sp>
+    </p:spTree>
+    <p:extLst>
+      <p:ext uri="{BB962C8B-B14F-4D97-AF65-F5344CB8AC3E}">
+        <p14:creationId xmlns:p14="http://schemas.microsoft.com/office/powerpoint/2010/main" val="1024086991"/>
+      </p:ext>
+    </p:extLst>
+  </p:cSld>
+  <p:clrMapOvr>
+    <a:masterClrMapping/>
+  </p:clrMapOvr>
+</p:notes>
+</file>
+
+<file path=ppt/notesSlides/notesSlide24.xml><?xml version="1.0" encoding="utf-8"?>
+<p:notes xmlns:a="http://schemas.openxmlformats.org/drawingml/2006/main" xmlns:r="http://schemas.openxmlformats.org/officeDocument/2006/relationships" xmlns:p="http://schemas.openxmlformats.org/presentationml/2006/main">
+  <p:cSld>
+    <p:spTree>
+      <p:nvGrpSpPr>
+        <p:cNvPr id="1" name=""/>
+        <p:cNvGrpSpPr/>
+        <p:nvPr/>
+      </p:nvGrpSpPr>
+      <p:grpSpPr>
+        <a:xfrm>
+          <a:off x="0" y="0"/>
+          <a:ext cx="0" cy="0"/>
+          <a:chOff x="0" y="0"/>
+          <a:chExt cx="0" cy="0"/>
+        </a:xfrm>
+      </p:grpSpPr>
+      <p:sp>
+        <p:nvSpPr>
+          <p:cNvPr id="2" name="Slide Image Placeholder 1"/>
+          <p:cNvSpPr>
+            <a:spLocks noGrp="1" noRot="1" noChangeAspect="1"/>
+          </p:cNvSpPr>
+          <p:nvPr>
+            <p:ph type="sldImg"/>
+          </p:nvPr>
+        </p:nvSpPr>
+        <p:spPr/>
+      </p:sp>
+      <p:sp>
+        <p:nvSpPr>
+          <p:cNvPr id="3" name="Notes Placeholder 2"/>
+          <p:cNvSpPr>
+            <a:spLocks noGrp="1"/>
+          </p:cNvSpPr>
+          <p:nvPr>
+            <p:ph type="body" idx="1"/>
+          </p:nvPr>
+        </p:nvSpPr>
+        <p:spPr/>
+        <p:txBody>
+          <a:bodyPr/>
+          <a:lstStyle/>
+          <a:p>
+            <a:r>
+              <a:rPr lang="en-US" dirty="0"/>
+              <a:t/>
+            </a:r>
+            <a:endParaRPr lang="en-US" dirty="0"/>
+          </a:p>
+        </p:txBody>
+      </p:sp>
+      <p:sp>
+        <p:nvSpPr>
+          <p:cNvPr id="4" name="Slide Number Placeholder 3"/>
+          <p:cNvSpPr>
+            <a:spLocks noGrp="1"/>
+          </p:cNvSpPr>
+          <p:nvPr>
+            <p:ph type="sldNum" sz="quarter" idx="10"/>
+          </p:nvPr>
+        </p:nvSpPr>
+        <p:spPr/>
+        <p:txBody>
+          <a:bodyPr/>
+          <a:lstStyle/>
+          <a:p>
+            <a:fld id="{F7021451-1387-4CA6-816F-3879F97B5CBC}" type="slidenum">
+              <a:rPr lang="en-US"/>
+              <a:t>24</a:t>
             </a:fld>
             <a:endParaRPr lang="en-US"/>
           </a:p>
@@ -3650,8 +3924,8 @@
         </p:blipFill>
         <p:spPr>
           <a:xfrm>
-            <a:off x="1348740" y="3473780"/>
-            <a:ext cx="3749040" cy="1373480"/>
+            <a:off x="1348740" y="3488846"/>
+            <a:ext cx="3749040" cy="1343349"/>
           </a:xfrm>
           <a:prstGeom prst="rect">
             <a:avLst/>
@@ -3737,8 +4011,8 @@
         </p:blipFill>
         <p:spPr>
           <a:xfrm>
-            <a:off x="7091172" y="3473780"/>
-            <a:ext cx="3749040" cy="1373480"/>
+            <a:off x="7091172" y="3488846"/>
+            <a:ext cx="3749040" cy="1343349"/>
           </a:xfrm>
           <a:prstGeom prst="rect">
             <a:avLst/>
@@ -4011,8 +4285,8 @@
         </p:blipFill>
         <p:spPr>
           <a:xfrm>
-            <a:off x="1348740" y="3473780"/>
-            <a:ext cx="3749040" cy="1373480"/>
+            <a:off x="1348740" y="3488846"/>
+            <a:ext cx="3749040" cy="1343349"/>
           </a:xfrm>
           <a:prstGeom prst="rect">
             <a:avLst/>
@@ -4098,8 +4372,8 @@
         </p:blipFill>
         <p:spPr>
           <a:xfrm>
-            <a:off x="7091172" y="3473780"/>
-            <a:ext cx="3749040" cy="1373480"/>
+            <a:off x="7091172" y="3488846"/>
+            <a:ext cx="3749040" cy="1343349"/>
           </a:xfrm>
           <a:prstGeom prst="rect">
             <a:avLst/>
@@ -4372,8 +4646,8 @@
         </p:blipFill>
         <p:spPr>
           <a:xfrm>
-            <a:off x="1348740" y="3473780"/>
-            <a:ext cx="3749040" cy="1373480"/>
+            <a:off x="1348740" y="3488846"/>
+            <a:ext cx="3749040" cy="1343349"/>
           </a:xfrm>
           <a:prstGeom prst="rect">
             <a:avLst/>
@@ -4459,8 +4733,8 @@
         </p:blipFill>
         <p:spPr>
           <a:xfrm>
-            <a:off x="7091172" y="3473780"/>
-            <a:ext cx="3749040" cy="1373480"/>
+            <a:off x="7091172" y="3488846"/>
+            <a:ext cx="3749040" cy="1343349"/>
           </a:xfrm>
           <a:prstGeom prst="rect">
             <a:avLst/>
@@ -4733,8 +5007,8 @@
         </p:blipFill>
         <p:spPr>
           <a:xfrm>
-            <a:off x="1348740" y="3473780"/>
-            <a:ext cx="3749040" cy="1373480"/>
+            <a:off x="1348740" y="3488846"/>
+            <a:ext cx="3749040" cy="1343349"/>
           </a:xfrm>
           <a:prstGeom prst="rect">
             <a:avLst/>
@@ -4820,8 +5094,8 @@
         </p:blipFill>
         <p:spPr>
           <a:xfrm>
-            <a:off x="7091172" y="3473780"/>
-            <a:ext cx="3749040" cy="1373480"/>
+            <a:off x="7091172" y="3488846"/>
+            <a:ext cx="3749040" cy="1343349"/>
           </a:xfrm>
           <a:prstGeom prst="rect">
             <a:avLst/>
@@ -5094,8 +5368,8 @@
         </p:blipFill>
         <p:spPr>
           <a:xfrm>
-            <a:off x="1348740" y="3473780"/>
-            <a:ext cx="3749040" cy="1373480"/>
+            <a:off x="1348740" y="3488846"/>
+            <a:ext cx="3749040" cy="1343349"/>
           </a:xfrm>
           <a:prstGeom prst="rect">
             <a:avLst/>
@@ -5181,8 +5455,8 @@
         </p:blipFill>
         <p:spPr>
           <a:xfrm>
-            <a:off x="7091172" y="3473780"/>
-            <a:ext cx="3749040" cy="1373480"/>
+            <a:off x="7091172" y="3488846"/>
+            <a:ext cx="3749040" cy="1343349"/>
           </a:xfrm>
           <a:prstGeom prst="rect">
             <a:avLst/>
@@ -5597,8 +5871,8 @@
         </p:blipFill>
         <p:spPr>
           <a:xfrm>
-            <a:off x="1348740" y="3473780"/>
-            <a:ext cx="3749040" cy="1373480"/>
+            <a:off x="1348740" y="3488846"/>
+            <a:ext cx="3749040" cy="1343349"/>
           </a:xfrm>
           <a:prstGeom prst="rect">
             <a:avLst/>
@@ -5684,8 +5958,8 @@
         </p:blipFill>
         <p:spPr>
           <a:xfrm>
-            <a:off x="7091172" y="3473780"/>
-            <a:ext cx="3749040" cy="1373480"/>
+            <a:off x="7091172" y="3488846"/>
+            <a:ext cx="3749040" cy="1343349"/>
           </a:xfrm>
           <a:prstGeom prst="rect">
             <a:avLst/>
@@ -5958,8 +6232,8 @@
         </p:blipFill>
         <p:spPr>
           <a:xfrm>
-            <a:off x="1348740" y="3473780"/>
-            <a:ext cx="3749040" cy="1373480"/>
+            <a:off x="1348740" y="3488846"/>
+            <a:ext cx="3749040" cy="1343349"/>
           </a:xfrm>
           <a:prstGeom prst="rect">
             <a:avLst/>
@@ -6045,8 +6319,8 @@
         </p:blipFill>
         <p:spPr>
           <a:xfrm>
-            <a:off x="7091172" y="3473780"/>
-            <a:ext cx="3749040" cy="1373480"/>
+            <a:off x="7091172" y="3488846"/>
+            <a:ext cx="3749040" cy="1343349"/>
           </a:xfrm>
           <a:prstGeom prst="rect">
             <a:avLst/>
@@ -6319,8 +6593,8 @@
         </p:blipFill>
         <p:spPr>
           <a:xfrm>
-            <a:off x="1348740" y="3473780"/>
-            <a:ext cx="3749040" cy="1373480"/>
+            <a:off x="1348740" y="3488846"/>
+            <a:ext cx="3749040" cy="1343349"/>
           </a:xfrm>
           <a:prstGeom prst="rect">
             <a:avLst/>
@@ -6406,8 +6680,8 @@
         </p:blipFill>
         <p:spPr>
           <a:xfrm>
-            <a:off x="7091172" y="3473780"/>
-            <a:ext cx="3749040" cy="1373480"/>
+            <a:off x="7091172" y="3488846"/>
+            <a:ext cx="3749040" cy="1343349"/>
           </a:xfrm>
           <a:prstGeom prst="rect">
             <a:avLst/>
@@ -6822,8 +7096,8 @@
         </p:blipFill>
         <p:spPr>
           <a:xfrm>
-            <a:off x="1348740" y="3473780"/>
-            <a:ext cx="3749040" cy="1373480"/>
+            <a:off x="1348740" y="3488846"/>
+            <a:ext cx="3749040" cy="1343349"/>
           </a:xfrm>
           <a:prstGeom prst="rect">
             <a:avLst/>
@@ -6909,8 +7183,8 @@
         </p:blipFill>
         <p:spPr>
           <a:xfrm>
-            <a:off x="7091172" y="3473780"/>
-            <a:ext cx="3749040" cy="1373480"/>
+            <a:off x="7091172" y="3488846"/>
+            <a:ext cx="3749040" cy="1343349"/>
           </a:xfrm>
           <a:prstGeom prst="rect">
             <a:avLst/>
@@ -7183,8 +7457,8 @@
         </p:blipFill>
         <p:spPr>
           <a:xfrm>
-            <a:off x="1348740" y="3473780"/>
-            <a:ext cx="3749040" cy="1373480"/>
+            <a:off x="1348740" y="3488846"/>
+            <a:ext cx="3749040" cy="1343349"/>
           </a:xfrm>
           <a:prstGeom prst="rect">
             <a:avLst/>
@@ -7270,8 +7544,8 @@
         </p:blipFill>
         <p:spPr>
           <a:xfrm>
-            <a:off x="7091172" y="3473780"/>
-            <a:ext cx="3749040" cy="1373480"/>
+            <a:off x="7091172" y="3488846"/>
+            <a:ext cx="3749040" cy="1343349"/>
           </a:xfrm>
           <a:prstGeom prst="rect">
             <a:avLst/>
@@ -7354,6 +7628,1668 @@
             <a:fld id="{F7021451-1387-4CA6-816F-3879F97B5CBC}" type="slidenum">
               <a:rPr b="0" lang="en-US"/>
               <a:t>21</a:t>
+            </a:fld>
+            <a:endParaRPr lang="en-US"/>
+          </a:p>
+        </p:txBody>
+      </p:sp>
+    </p:spTree>
+  </p:cSld>
+  <p:clrMapOvr>
+    <a:masterClrMapping/>
+  </p:clrMapOvr>
+</p:sld>
+</file>
+
+<file path=ppt/slides/slide22.xml><?xml version="1.0" encoding="utf-8"?>
+<p:sld xmlns:a="http://schemas.openxmlformats.org/drawingml/2006/main" xmlns:r="http://schemas.openxmlformats.org/officeDocument/2006/relationships" xmlns:p="http://schemas.openxmlformats.org/presentationml/2006/main">
+  <p:cSld name="Slide 22">
+    <p:spTree>
+      <p:nvGrpSpPr>
+        <p:cNvPr id="1" name=""/>
+        <p:cNvGrpSpPr/>
+        <p:nvPr/>
+      </p:nvGrpSpPr>
+      <p:grpSpPr>
+        <a:xfrm>
+          <a:off x="0" y="0"/>
+          <a:ext cx="0" cy="0"/>
+          <a:chOff x="0" y="0"/>
+          <a:chExt cx="0" cy="0"/>
+        </a:xfrm>
+      </p:grpSpPr>
+      <p:sp>
+        <p:nvSpPr>
+          <p:cNvPr id="2" name="Text 0"/>
+          <p:cNvSpPr/>
+          <p:nvPr>
+            <p:ph idx="100" type="body" hasCustomPrompt="1"/>
+          </p:nvPr>
+        </p:nvSpPr>
+        <p:spPr>
+          <a:xfrm>
+            <a:off x="731520" y="2011680"/>
+            <a:ext cx="5486400" cy="457200"/>
+          </a:xfrm>
+          <a:prstGeom prst="rect">
+            <a:avLst/>
+          </a:prstGeom>
+          <a:noFill/>
+          <a:ln/>
+        </p:spPr>
+        <p:txBody>
+          <a:bodyPr wrap="square" lIns="0" tIns="0" rIns="0" bIns="0" rtlCol="0"/>
+          <a:lstStyle/>
+          <a:p>
+            <a:pPr indent="0" marL="0">
+              <a:buNone/>
+            </a:pPr>
+            <a:r>
+              <a:rPr lang="en-US" sz="1400" spc="400" kern="0" dirty="0">
+                <a:solidFill>
+                  <a:schemeClr val="accent1"/>
+                </a:solidFill>
+              </a:rPr>
+              <a:t>COMÚN A TODAS LAS MARCAS</a:t>
+            </a:r>
+            <a:endParaRPr lang="en-US" sz="1400" dirty="0"/>
+          </a:p>
+        </p:txBody>
+      </p:sp>
+      <p:sp>
+        <p:nvSpPr>
+          <p:cNvPr id="3" name="Text 0"/>
+          <p:cNvSpPr/>
+          <p:nvPr>
+            <p:ph idx="101" type="title" hasCustomPrompt="1"/>
+          </p:nvPr>
+        </p:nvSpPr>
+        <p:spPr>
+          <a:xfrm>
+            <a:off x="731520" y="2560320"/>
+            <a:ext cx="10698480" cy="1280160"/>
+          </a:xfrm>
+          <a:prstGeom prst="rect">
+            <a:avLst/>
+          </a:prstGeom>
+          <a:noFill/>
+          <a:ln/>
+        </p:spPr>
+        <p:txBody>
+          <a:bodyPr wrap="square" lIns="0" tIns="0" rIns="0" bIns="0" rtlCol="0" anchor="t"/>
+          <a:lstStyle/>
+          <a:p>
+            <a:pPr algn="l" indent="0" marL="0">
+              <a:buNone/>
+            </a:pPr>
+            <a:r>
+              <a:rPr lang="en-US" sz="5400" b="1" dirty="0">
+                <a:solidFill>
+                  <a:schemeClr val="bg2"/>
+                </a:solidFill>
+              </a:rPr>
+              <a:t>Sistema de identidad</a:t>
+            </a:r>
+            <a:endParaRPr lang="en-US" sz="5400" dirty="0"/>
+          </a:p>
+        </p:txBody>
+      </p:sp>
+      <p:sp>
+        <p:nvSpPr>
+          <p:cNvPr id="4" name="Text 0"/>
+          <p:cNvSpPr/>
+          <p:nvPr>
+            <p:ph idx="102" type="body" hasCustomPrompt="1"/>
+          </p:nvPr>
+        </p:nvSpPr>
+        <p:spPr>
+          <a:xfrm>
+            <a:off x="731520" y="3931920"/>
+            <a:ext cx="8778240" cy="1645920"/>
+          </a:xfrm>
+          <a:prstGeom prst="rect">
+            <a:avLst/>
+          </a:prstGeom>
+          <a:noFill/>
+          <a:ln/>
+        </p:spPr>
+        <p:txBody>
+          <a:bodyPr wrap="square" lIns="0" tIns="0" rIns="0" bIns="0" rtlCol="0" anchor="t"/>
+          <a:lstStyle/>
+          <a:p>
+            <a:pPr indent="0" marL="0">
+              <a:lnSpc>
+                <a:spcPct val="120000"/>
+              </a:lnSpc>
+              <a:buNone/>
+            </a:pPr>
+            <a:r>
+              <a:rPr lang="en-US" sz="1800" dirty="0">
+                <a:solidFill>
+                  <a:schemeClr val="accent5"/>
+                </a:solidFill>
+              </a:rPr>
+              <a:t>Una paleta nacida del paisaje misionero, una tipografía en dos niveles y reglas pensadas para imprimir a una tinta sobre kraft.</a:t>
+            </a:r>
+            <a:endParaRPr lang="en-US" sz="1800" dirty="0"/>
+          </a:p>
+        </p:txBody>
+      </p:sp>
+    </p:spTree>
+  </p:cSld>
+  <p:clrMapOvr>
+    <a:masterClrMapping/>
+  </p:clrMapOvr>
+</p:sld>
+</file>
+
+<file path=ppt/slides/slide23.xml><?xml version="1.0" encoding="utf-8"?>
+<p:sld xmlns:a="http://schemas.openxmlformats.org/drawingml/2006/main" xmlns:r="http://schemas.openxmlformats.org/officeDocument/2006/relationships" xmlns:p="http://schemas.openxmlformats.org/presentationml/2006/main">
+  <p:cSld name="Slide 23">
+    <p:spTree>
+      <p:nvGrpSpPr>
+        <p:cNvPr id="1" name=""/>
+        <p:cNvGrpSpPr/>
+        <p:nvPr/>
+      </p:nvGrpSpPr>
+      <p:grpSpPr>
+        <a:xfrm>
+          <a:off x="0" y="0"/>
+          <a:ext cx="0" cy="0"/>
+          <a:chOff x="0" y="0"/>
+          <a:chExt cx="0" cy="0"/>
+        </a:xfrm>
+      </p:grpSpPr>
+      <p:sp>
+        <p:nvSpPr>
+          <p:cNvPr id="2" name="Text 0"/>
+          <p:cNvSpPr/>
+          <p:nvPr>
+            <p:ph idx="100" type="title" hasCustomPrompt="1"/>
+          </p:nvPr>
+        </p:nvSpPr>
+        <p:spPr>
+          <a:xfrm>
+            <a:off x="457200" y="365760"/>
+            <a:ext cx="8686800" cy="685800"/>
+          </a:xfrm>
+          <a:prstGeom prst="rect">
+            <a:avLst/>
+          </a:prstGeom>
+          <a:noFill/>
+          <a:ln/>
+        </p:spPr>
+        <p:txBody>
+          <a:bodyPr wrap="square" lIns="0" tIns="0" rIns="0" bIns="0" rtlCol="0" anchor="ctr"/>
+          <a:lstStyle/>
+          <a:p>
+            <a:pPr algn="l" indent="0" marL="0">
+              <a:buNone/>
+            </a:pPr>
+            <a:r>
+              <a:rPr lang="en-US" sz="3000" b="1" dirty="0">
+                <a:solidFill>
+                  <a:schemeClr val="tx1"/>
+                </a:solidFill>
+              </a:rPr>
+              <a:t>Paleta, tipografía y reglas</a:t>
+            </a:r>
+            <a:endParaRPr lang="en-US" sz="3000" dirty="0"/>
+          </a:p>
+        </p:txBody>
+      </p:sp>
+      <p:sp>
+        <p:nvSpPr>
+          <p:cNvPr id="3" name="Text 0"/>
+          <p:cNvSpPr/>
+          <p:nvPr>
+            <p:ph idx="101" type="body" hasCustomPrompt="1"/>
+          </p:nvPr>
+        </p:nvSpPr>
+        <p:spPr>
+          <a:xfrm>
+            <a:off x="457200" y="1005840"/>
+            <a:ext cx="8686800" cy="365760"/>
+          </a:xfrm>
+          <a:prstGeom prst="rect">
+            <a:avLst/>
+          </a:prstGeom>
+          <a:noFill/>
+          <a:ln/>
+        </p:spPr>
+        <p:txBody>
+          <a:bodyPr wrap="square" lIns="0" tIns="0" rIns="0" bIns="0" rtlCol="0" anchor="t"/>
+          <a:lstStyle/>
+          <a:p>
+            <a:pPr indent="0" marL="0">
+              <a:buNone/>
+            </a:pPr>
+            <a:r>
+              <a:rPr lang="en-US" sz="1200" spc="300" kern="0" dirty="0">
+                <a:solidFill>
+                  <a:schemeClr val="accent6"/>
+                </a:solidFill>
+              </a:rPr>
+              <a:t>SISTEMA · COMÚN A TODAS LAS MARCAS FINALISTAS</a:t>
+            </a:r>
+            <a:endParaRPr lang="en-US" sz="1200" dirty="0"/>
+          </a:p>
+        </p:txBody>
+      </p:sp>
+      <p:sp>
+        <p:nvSpPr>
+          <p:cNvPr id="4" name="Color Verde selva"/>
+          <p:cNvSpPr/>
+          <p:nvPr/>
+        </p:nvSpPr>
+        <p:spPr>
+          <a:xfrm>
+            <a:off x="457200" y="1600200"/>
+            <a:ext cx="2103120" cy="2103120"/>
+          </a:xfrm>
+          <a:prstGeom prst="roundRect">
+            <a:avLst>
+              <a:gd name="adj" fmla="val 5217"/>
+            </a:avLst>
+          </a:prstGeom>
+          <a:solidFill>
+            <a:schemeClr val="tx1"/>
+          </a:solidFill>
+          <a:ln w="12700">
+            <a:solidFill>
+              <a:schemeClr val="tx1"/>
+            </a:solidFill>
+            <a:prstDash val="solid"/>
+          </a:ln>
+        </p:spPr>
+      </p:sp>
+      <p:sp>
+        <p:nvSpPr>
+          <p:cNvPr id="5" name="Dato Verde selva"/>
+          <p:cNvSpPr txBox="1"/>
+          <p:nvPr/>
+        </p:nvSpPr>
+        <p:spPr>
+          <a:xfrm>
+            <a:off x="640080" y="2880360"/>
+            <a:ext cx="1783080" cy="685800"/>
+          </a:xfrm>
+          <a:prstGeom prst="rect">
+            <a:avLst/>
+          </a:prstGeom>
+          <a:noFill/>
+          <a:ln/>
+        </p:spPr>
+        <p:txBody>
+          <a:bodyPr wrap="square" lIns="0" tIns="0" rIns="0" bIns="0" rtlCol="0" anchor="b"/>
+          <a:lstStyle/>
+          <a:p>
+            <a:pPr indent="0" marL="0">
+              <a:buNone/>
+            </a:pPr>
+            <a:r>
+              <a:rPr lang="en-US" sz="1600" b="1" dirty="0">
+                <a:solidFill>
+                  <a:schemeClr val="bg2"/>
+                </a:solidFill>
+              </a:rPr>
+              <a:t>Verde selva</a:t>
+            </a:r>
+            <a:endParaRPr lang="en-US" sz="1600" dirty="0"/>
+          </a:p>
+          <a:p>
+            <a:pPr indent="0" marL="0">
+              <a:buNone/>
+            </a:pPr>
+            <a:r>
+              <a:rPr lang="en-US" sz="1200" dirty="0">
+                <a:solidFill>
+                  <a:schemeClr val="bg2"/>
+                </a:solidFill>
+              </a:rPr>
+              <a:t>#1F3A2B · tinta principal</a:t>
+            </a:r>
+            <a:endParaRPr lang="en-US" sz="1600" dirty="0"/>
+          </a:p>
+        </p:txBody>
+      </p:sp>
+      <p:sp>
+        <p:nvSpPr>
+          <p:cNvPr id="6" name="Color Kraft"/>
+          <p:cNvSpPr/>
+          <p:nvPr/>
+        </p:nvSpPr>
+        <p:spPr>
+          <a:xfrm>
+            <a:off x="2743200" y="1600200"/>
+            <a:ext cx="2103120" cy="2103120"/>
+          </a:xfrm>
+          <a:prstGeom prst="roundRect">
+            <a:avLst>
+              <a:gd name="adj" fmla="val 5217"/>
+            </a:avLst>
+          </a:prstGeom>
+          <a:solidFill>
+            <a:schemeClr val="accent1"/>
+          </a:solidFill>
+          <a:ln w="12700">
+            <a:solidFill>
+              <a:schemeClr val="accent1"/>
+            </a:solidFill>
+            <a:prstDash val="solid"/>
+          </a:ln>
+        </p:spPr>
+      </p:sp>
+      <p:sp>
+        <p:nvSpPr>
+          <p:cNvPr id="7" name="Dato Kraft"/>
+          <p:cNvSpPr txBox="1"/>
+          <p:nvPr/>
+        </p:nvSpPr>
+        <p:spPr>
+          <a:xfrm>
+            <a:off x="2926080" y="2880360"/>
+            <a:ext cx="1783080" cy="685800"/>
+          </a:xfrm>
+          <a:prstGeom prst="rect">
+            <a:avLst/>
+          </a:prstGeom>
+          <a:noFill/>
+          <a:ln/>
+        </p:spPr>
+        <p:txBody>
+          <a:bodyPr wrap="square" lIns="0" tIns="0" rIns="0" bIns="0" rtlCol="0" anchor="b"/>
+          <a:lstStyle/>
+          <a:p>
+            <a:pPr indent="0" marL="0">
+              <a:buNone/>
+            </a:pPr>
+            <a:r>
+              <a:rPr lang="en-US" sz="1600" b="1" dirty="0">
+                <a:solidFill>
+                  <a:schemeClr val="tx1"/>
+                </a:solidFill>
+              </a:rPr>
+              <a:t>Kraft</a:t>
+            </a:r>
+            <a:endParaRPr lang="en-US" sz="1600" dirty="0"/>
+          </a:p>
+          <a:p>
+            <a:pPr indent="0" marL="0">
+              <a:buNone/>
+            </a:pPr>
+            <a:r>
+              <a:rPr lang="en-US" sz="1200" dirty="0">
+                <a:solidFill>
+                  <a:schemeClr val="tx1"/>
+                </a:solidFill>
+              </a:rPr>
+              <a:t>#B98A57 · soporte y acento</a:t>
+            </a:r>
+            <a:endParaRPr lang="en-US" sz="1600" dirty="0"/>
+          </a:p>
+        </p:txBody>
+      </p:sp>
+      <p:sp>
+        <p:nvSpPr>
+          <p:cNvPr id="8" name="Color Kraft oscuro"/>
+          <p:cNvSpPr/>
+          <p:nvPr/>
+        </p:nvSpPr>
+        <p:spPr>
+          <a:xfrm>
+            <a:off x="5029200" y="1600200"/>
+            <a:ext cx="2103120" cy="2103120"/>
+          </a:xfrm>
+          <a:prstGeom prst="roundRect">
+            <a:avLst>
+              <a:gd name="adj" fmla="val 5217"/>
+            </a:avLst>
+          </a:prstGeom>
+          <a:solidFill>
+            <a:schemeClr val="accent3"/>
+          </a:solidFill>
+          <a:ln w="12700">
+            <a:solidFill>
+              <a:schemeClr val="accent3"/>
+            </a:solidFill>
+            <a:prstDash val="solid"/>
+          </a:ln>
+        </p:spPr>
+      </p:sp>
+      <p:sp>
+        <p:nvSpPr>
+          <p:cNvPr id="9" name="Dato Kraft oscuro"/>
+          <p:cNvSpPr txBox="1"/>
+          <p:nvPr/>
+        </p:nvSpPr>
+        <p:spPr>
+          <a:xfrm>
+            <a:off x="5212080" y="2880360"/>
+            <a:ext cx="1783080" cy="685800"/>
+          </a:xfrm>
+          <a:prstGeom prst="rect">
+            <a:avLst/>
+          </a:prstGeom>
+          <a:noFill/>
+          <a:ln/>
+        </p:spPr>
+        <p:txBody>
+          <a:bodyPr wrap="square" lIns="0" tIns="0" rIns="0" bIns="0" rtlCol="0" anchor="b"/>
+          <a:lstStyle/>
+          <a:p>
+            <a:pPr indent="0" marL="0">
+              <a:buNone/>
+            </a:pPr>
+            <a:r>
+              <a:rPr lang="en-US" sz="1600" b="1" dirty="0">
+                <a:solidFill>
+                  <a:schemeClr val="bg2"/>
+                </a:solidFill>
+              </a:rPr>
+              <a:t>Kraft oscuro</a:t>
+            </a:r>
+            <a:endParaRPr lang="en-US" sz="1600" dirty="0"/>
+          </a:p>
+          <a:p>
+            <a:pPr indent="0" marL="0">
+              <a:buNone/>
+            </a:pPr>
+            <a:r>
+              <a:rPr lang="en-US" sz="1200" dirty="0">
+                <a:solidFill>
+                  <a:schemeClr val="bg2"/>
+                </a:solidFill>
+              </a:rPr>
+              <a:t>#8E6538</a:t>
+            </a:r>
+            <a:endParaRPr lang="en-US" sz="1600" dirty="0"/>
+          </a:p>
+        </p:txBody>
+      </p:sp>
+      <p:sp>
+        <p:nvSpPr>
+          <p:cNvPr id="10" name="Color Tierra colorada"/>
+          <p:cNvSpPr/>
+          <p:nvPr/>
+        </p:nvSpPr>
+        <p:spPr>
+          <a:xfrm>
+            <a:off x="7315200" y="1600200"/>
+            <a:ext cx="2103120" cy="2103120"/>
+          </a:xfrm>
+          <a:prstGeom prst="roundRect">
+            <a:avLst>
+              <a:gd name="adj" fmla="val 5217"/>
+            </a:avLst>
+          </a:prstGeom>
+          <a:solidFill>
+            <a:schemeClr val="accent2"/>
+          </a:solidFill>
+          <a:ln w="12700">
+            <a:solidFill>
+              <a:schemeClr val="accent2"/>
+            </a:solidFill>
+            <a:prstDash val="solid"/>
+          </a:ln>
+        </p:spPr>
+      </p:sp>
+      <p:sp>
+        <p:nvSpPr>
+          <p:cNvPr id="11" name="Dato Tierra colorada"/>
+          <p:cNvSpPr txBox="1"/>
+          <p:nvPr/>
+        </p:nvSpPr>
+        <p:spPr>
+          <a:xfrm>
+            <a:off x="7498080" y="2880360"/>
+            <a:ext cx="1783080" cy="685800"/>
+          </a:xfrm>
+          <a:prstGeom prst="rect">
+            <a:avLst/>
+          </a:prstGeom>
+          <a:noFill/>
+          <a:ln/>
+        </p:spPr>
+        <p:txBody>
+          <a:bodyPr wrap="square" lIns="0" tIns="0" rIns="0" bIns="0" rtlCol="0" anchor="b"/>
+          <a:lstStyle/>
+          <a:p>
+            <a:pPr indent="0" marL="0">
+              <a:buNone/>
+            </a:pPr>
+            <a:r>
+              <a:rPr lang="en-US" sz="1600" b="1" dirty="0">
+                <a:solidFill>
+                  <a:schemeClr val="bg2"/>
+                </a:solidFill>
+              </a:rPr>
+              <a:t>Tierra colorada</a:t>
+            </a:r>
+            <a:endParaRPr lang="en-US" sz="1600" dirty="0"/>
+          </a:p>
+          <a:p>
+            <a:pPr indent="0" marL="0">
+              <a:buNone/>
+            </a:pPr>
+            <a:r>
+              <a:rPr lang="en-US" sz="1200" dirty="0">
+                <a:solidFill>
+                  <a:schemeClr val="bg2"/>
+                </a:solidFill>
+              </a:rPr>
+              <a:t>#B0452B · acento</a:t>
+            </a:r>
+            <a:endParaRPr lang="en-US" sz="1600" dirty="0"/>
+          </a:p>
+        </p:txBody>
+      </p:sp>
+      <p:sp>
+        <p:nvSpPr>
+          <p:cNvPr id="12" name="Color Papel crudo"/>
+          <p:cNvSpPr/>
+          <p:nvPr/>
+        </p:nvSpPr>
+        <p:spPr>
+          <a:xfrm>
+            <a:off x="9601200" y="1600200"/>
+            <a:ext cx="2103120" cy="2103120"/>
+          </a:xfrm>
+          <a:prstGeom prst="roundRect">
+            <a:avLst>
+              <a:gd name="adj" fmla="val 5217"/>
+            </a:avLst>
+          </a:prstGeom>
+          <a:solidFill>
+            <a:schemeClr val="bg2"/>
+          </a:solidFill>
+          <a:ln w="12700">
+            <a:solidFill>
+              <a:schemeClr val="accent5"/>
+            </a:solidFill>
+            <a:prstDash val="solid"/>
+          </a:ln>
+        </p:spPr>
+      </p:sp>
+      <p:sp>
+        <p:nvSpPr>
+          <p:cNvPr id="13" name="Dato Papel crudo"/>
+          <p:cNvSpPr txBox="1"/>
+          <p:nvPr/>
+        </p:nvSpPr>
+        <p:spPr>
+          <a:xfrm>
+            <a:off x="9784080" y="2880360"/>
+            <a:ext cx="1783080" cy="685800"/>
+          </a:xfrm>
+          <a:prstGeom prst="rect">
+            <a:avLst/>
+          </a:prstGeom>
+          <a:noFill/>
+          <a:ln/>
+        </p:spPr>
+        <p:txBody>
+          <a:bodyPr wrap="square" lIns="0" tIns="0" rIns="0" bIns="0" rtlCol="0" anchor="b"/>
+          <a:lstStyle/>
+          <a:p>
+            <a:pPr indent="0" marL="0">
+              <a:buNone/>
+            </a:pPr>
+            <a:r>
+              <a:rPr lang="en-US" sz="1600" b="1" dirty="0">
+                <a:solidFill>
+                  <a:schemeClr val="tx1"/>
+                </a:solidFill>
+              </a:rPr>
+              <a:t>Papel crudo</a:t>
+            </a:r>
+            <a:endParaRPr lang="en-US" sz="1600" dirty="0"/>
+          </a:p>
+          <a:p>
+            <a:pPr indent="0" marL="0">
+              <a:buNone/>
+            </a:pPr>
+            <a:r>
+              <a:rPr lang="en-US" sz="1200" dirty="0">
+                <a:solidFill>
+                  <a:schemeClr val="tx1"/>
+                </a:solidFill>
+              </a:rPr>
+              <a:t>#F2EADB · fondo</a:t>
+            </a:r>
+            <a:endParaRPr lang="en-US" sz="1600" dirty="0"/>
+          </a:p>
+        </p:txBody>
+      </p:sp>
+      <p:sp>
+        <p:nvSpPr>
+          <p:cNvPr id="14" name="Tipografía"/>
+          <p:cNvSpPr/>
+          <p:nvPr/>
+        </p:nvSpPr>
+        <p:spPr>
+          <a:xfrm>
+            <a:off x="457200" y="3931920"/>
+            <a:ext cx="6400800" cy="2240280"/>
+          </a:xfrm>
+          <a:prstGeom prst="roundRect">
+            <a:avLst>
+              <a:gd name="adj" fmla="val 4898"/>
+            </a:avLst>
+          </a:prstGeom>
+          <a:solidFill>
+            <a:schemeClr val="bg1"/>
+          </a:solidFill>
+          <a:ln w="12700">
+            <a:solidFill>
+              <a:schemeClr val="bg1"/>
+            </a:solidFill>
+            <a:prstDash val="solid"/>
+          </a:ln>
+        </p:spPr>
+      </p:sp>
+      <p:sp>
+        <p:nvSpPr>
+          <p:cNvPr id="15" name="Muestra tipográfica"/>
+          <p:cNvSpPr txBox="1"/>
+          <p:nvPr/>
+        </p:nvSpPr>
+        <p:spPr>
+          <a:xfrm>
+            <a:off x="777240" y="4069080"/>
+            <a:ext cx="5852160" cy="1965960"/>
+          </a:xfrm>
+          <a:prstGeom prst="rect">
+            <a:avLst/>
+          </a:prstGeom>
+          <a:noFill/>
+          <a:ln/>
+        </p:spPr>
+        <p:txBody>
+          <a:bodyPr wrap="square" lIns="0" tIns="0" rIns="0" bIns="0" rtlCol="0" anchor="ctr"/>
+          <a:lstStyle/>
+          <a:p>
+            <a:pPr indent="0" marL="0">
+              <a:buNone/>
+            </a:pPr>
+            <a:r>
+              <a:rPr lang="en-US" sz="1600" spc="1000" kern="0" dirty="0">
+                <a:solidFill>
+                  <a:schemeClr val="tx1"/>
+                </a:solidFill>
+              </a:rPr>
+              <a:t>PAPEL</a:t>
+            </a:r>
+            <a:endParaRPr lang="en-US" sz="1600" dirty="0"/>
+          </a:p>
+          <a:p>
+            <a:pPr indent="0" marL="0">
+              <a:buNone/>
+            </a:pPr>
+            <a:r>
+              <a:rPr lang="en-US" sz="6600" b="1" spc="-200" kern="0" dirty="0">
+                <a:solidFill>
+                  <a:schemeClr val="tx1"/>
+                </a:solidFill>
+              </a:rPr>
+              <a:t>misionero</a:t>
+            </a:r>
+            <a:endParaRPr lang="en-US" sz="1600" dirty="0"/>
+          </a:p>
+          <a:p>
+            <a:pPr indent="0" marL="0">
+              <a:buNone/>
+            </a:pPr>
+            <a:r>
+              <a:rPr lang="en-US" sz="1200" dirty="0">
+                <a:solidFill>
+                  <a:schemeClr val="accent6"/>
+                </a:solidFill>
+              </a:rPr>
+              <a:t>Helvetica Regular espaciada + Helvetica Bold apretada. Dos niveles: el origen manda.</a:t>
+            </a:r>
+            <a:endParaRPr lang="en-US" sz="1600" dirty="0"/>
+          </a:p>
+        </p:txBody>
+      </p:sp>
+      <p:sp>
+        <p:nvSpPr>
+          <p:cNvPr id="16" name="Reglas"/>
+          <p:cNvSpPr/>
+          <p:nvPr/>
+        </p:nvSpPr>
+        <p:spPr>
+          <a:xfrm>
+            <a:off x="7040880" y="3931920"/>
+            <a:ext cx="4690872" cy="2240280"/>
+          </a:xfrm>
+          <a:prstGeom prst="roundRect">
+            <a:avLst>
+              <a:gd name="adj" fmla="val 4898"/>
+            </a:avLst>
+          </a:prstGeom>
+          <a:solidFill>
+            <a:schemeClr val="bg1"/>
+          </a:solidFill>
+          <a:ln w="12700">
+            <a:solidFill>
+              <a:schemeClr val="bg1"/>
+            </a:solidFill>
+            <a:prstDash val="solid"/>
+          </a:ln>
+        </p:spPr>
+      </p:sp>
+      <p:sp>
+        <p:nvSpPr>
+          <p:cNvPr id="17" name="Lista de reglas"/>
+          <p:cNvSpPr txBox="1"/>
+          <p:nvPr/>
+        </p:nvSpPr>
+        <p:spPr>
+          <a:xfrm>
+            <a:off x="7315200" y="4114800"/>
+            <a:ext cx="4206240" cy="1920240"/>
+          </a:xfrm>
+          <a:prstGeom prst="rect">
+            <a:avLst/>
+          </a:prstGeom>
+          <a:noFill/>
+          <a:ln/>
+        </p:spPr>
+        <p:txBody>
+          <a:bodyPr wrap="square" lIns="0" tIns="0" rIns="0" bIns="0" rtlCol="0" anchor="t"/>
+          <a:lstStyle/>
+          <a:p>
+            <a:pPr indent="0" marL="0">
+              <a:spcAft>
+                <a:spcPts val="400"/>
+              </a:spcAft>
+              <a:buNone/>
+            </a:pPr>
+            <a:r>
+              <a:rPr lang="en-US" sz="1600" b="1" dirty="0">
+                <a:solidFill>
+                  <a:schemeClr val="tx1"/>
+                </a:solidFill>
+              </a:rPr>
+              <a:t>Reglas</a:t>
+            </a:r>
+            <a:endParaRPr lang="en-US" sz="1600" dirty="0"/>
+          </a:p>
+          <a:p>
+            <a:pPr marL="342900" indent="-342900">
+              <a:spcAft>
+                <a:spcPts val="400"/>
+              </a:spcAft>
+              <a:buSzPct val="100000"/>
+              <a:buChar char="•"/>
+            </a:pPr>
+            <a:r>
+              <a:rPr lang="en-US" sz="1400" dirty="0">
+                <a:solidFill>
+                  <a:schemeClr val="tx1"/>
+                </a:solidFill>
+              </a:rPr>
+              <a:t>Una sola tinta: verde selva, o kraft y crudo en negativo.</a:t>
+            </a:r>
+            <a:endParaRPr lang="en-US" sz="1600" dirty="0"/>
+          </a:p>
+          <a:p>
+            <a:pPr marL="342900" indent="-342900">
+              <a:spcAft>
+                <a:spcPts val="400"/>
+              </a:spcAft>
+              <a:buSzPct val="100000"/>
+              <a:buChar char="•"/>
+            </a:pPr>
+            <a:r>
+              <a:rPr lang="en-US" sz="1400" dirty="0">
+                <a:solidFill>
+                  <a:schemeClr val="tx1"/>
+                </a:solidFill>
+              </a:rPr>
+              <a:t>Calado mínimo de 5 unidades para flexografía.</a:t>
+            </a:r>
+            <a:endParaRPr lang="en-US" sz="1600" dirty="0"/>
+          </a:p>
+          <a:p>
+            <a:pPr marL="342900" indent="-342900">
+              <a:spcAft>
+                <a:spcPts val="400"/>
+              </a:spcAft>
+              <a:buSzPct val="100000"/>
+              <a:buChar char="•"/>
+            </a:pPr>
+            <a:r>
+              <a:rPr lang="en-US" sz="1400" dirty="0">
+                <a:solidFill>
+                  <a:schemeClr val="tx1"/>
+                </a:solidFill>
+              </a:rPr>
+              <a:t>Isotipo a 1,3 veces la altura del bloque de texto.</a:t>
+            </a:r>
+            <a:endParaRPr lang="en-US" sz="1600" dirty="0"/>
+          </a:p>
+          <a:p>
+            <a:pPr marL="342900" indent="-342900">
+              <a:spcAft>
+                <a:spcPts val="400"/>
+              </a:spcAft>
+              <a:buSzPct val="100000"/>
+              <a:buChar char="•"/>
+            </a:pPr>
+            <a:r>
+              <a:rPr lang="en-US" sz="1400" dirty="0">
+                <a:solidFill>
+                  <a:schemeClr val="tx1"/>
+                </a:solidFill>
+              </a:rPr>
+              <a:t>Margen de respeto: la altura de «PAPEL» alrededor.</a:t>
+            </a:r>
+            <a:endParaRPr lang="en-US" sz="1600" dirty="0"/>
+          </a:p>
+          <a:p>
+            <a:pPr marL="342900" indent="-342900">
+              <a:spcAft>
+                <a:spcPts val="400"/>
+              </a:spcAft>
+              <a:buSzPct val="100000"/>
+              <a:buChar char="•"/>
+            </a:pPr>
+            <a:r>
+              <a:rPr lang="en-US" sz="1400" dirty="0">
+                <a:solidFill>
+                  <a:schemeClr val="tx1"/>
+                </a:solidFill>
+              </a:rPr>
+              <a:t>Tamaño mínimo del isotipo: 16 px / 6 mm.</a:t>
+            </a:r>
+            <a:endParaRPr lang="en-US" sz="1600" dirty="0"/>
+          </a:p>
+        </p:txBody>
+      </p:sp>
+      <p:sp>
+        <p:nvSpPr>
+          <p:cNvPr id="18" name="Text 0"/>
+          <p:cNvSpPr/>
+          <p:nvPr>
+            <p:ph idx="102" type="body" hasCustomPrompt="1"/>
+          </p:nvPr>
+        </p:nvSpPr>
+        <p:spPr>
+          <a:xfrm>
+            <a:off x="457200" y="1417320"/>
+            <a:ext cx="11247120" cy="777240"/>
+          </a:xfrm>
+          <a:prstGeom prst="rect">
+            <a:avLst/>
+          </a:prstGeom>
+          <a:noFill/>
+          <a:ln/>
+        </p:spPr>
+        <p:txBody>
+          <a:bodyPr wrap="square" lIns="0" tIns="0" rIns="0" bIns="0" rtlCol="0" anchor="t"/>
+          <a:lstStyle/>
+          <a:p>
+            <a:pPr indent="0" marL="0">
+              <a:lnSpc>
+                <a:spcPct val="115000"/>
+              </a:lnSpc>
+              <a:buNone/>
+            </a:pPr>
+            <a:endParaRPr lang="en-US" sz="1500" dirty="0"/>
+          </a:p>
+        </p:txBody>
+      </p:sp>
+      <p:sp>
+        <p:nvSpPr>
+          <p:cNvPr id="25" name="Slide Number Placeholder 0"/>
+          <p:cNvSpPr>
+            <a:spLocks noGrp="1"/>
+          </p:cNvSpPr>
+          <p:nvPr>
+            <p:ph type="sldNum" sz="quarter" idx="4294967295"/>
+          </p:nvPr>
+        </p:nvSpPr>
+        <p:spPr>
+          <a:xfrm>
+            <a:off x="11247120" y="6400800"/>
+            <a:ext cx="502920" cy="274320"/>
+          </a:xfrm>
+          <a:prstGeom prst="rect">
+            <a:avLst/>
+          </a:prstGeom>
+          <a:extLst>
+            <a:ext uri="{C572A759-6A51-4108-AA02-DFA0A04FC94B}">
+              <ma14:wrappingTextBoxFlag xmlns:ma14="http://schemas.microsoft.com/office/mac/drawingml/2011/main" val="0"/>
+            </a:ext>
+          </a:extLst>
+        </p:spPr>
+        <p:txBody>
+          <a:bodyPr/>
+          <a:lstStyle>
+            <a:lvl1pPr>
+              <a:defRPr sz="1000">
+                <a:solidFill>
+                  <a:schemeClr val="accent6"/>
+                </a:solidFill>
+              </a:defRPr>
+            </a:lvl1pPr>
+          </a:lstStyle>
+          <a:p>
+            <a:pPr algn="r"/>
+            <a:fld id="{F7021451-1387-4CA6-816F-3879F97B5CBC}" type="slidenum">
+              <a:rPr b="0" lang="en-US"/>
+              <a:t>23</a:t>
+            </a:fld>
+            <a:endParaRPr lang="en-US"/>
+          </a:p>
+        </p:txBody>
+      </p:sp>
+    </p:spTree>
+  </p:cSld>
+  <p:clrMapOvr>
+    <a:masterClrMapping/>
+  </p:clrMapOvr>
+</p:sld>
+</file>
+
+<file path=ppt/slides/slide24.xml><?xml version="1.0" encoding="utf-8"?>
+<p:sld xmlns:a="http://schemas.openxmlformats.org/drawingml/2006/main" xmlns:r="http://schemas.openxmlformats.org/officeDocument/2006/relationships" xmlns:p="http://schemas.openxmlformats.org/presentationml/2006/main">
+  <p:cSld name="Slide 24">
+    <p:spTree>
+      <p:nvGrpSpPr>
+        <p:cNvPr id="1" name=""/>
+        <p:cNvGrpSpPr/>
+        <p:nvPr/>
+      </p:nvGrpSpPr>
+      <p:grpSpPr>
+        <a:xfrm>
+          <a:off x="0" y="0"/>
+          <a:ext cx="0" cy="0"/>
+          <a:chOff x="0" y="0"/>
+          <a:chExt cx="0" cy="0"/>
+        </a:xfrm>
+      </p:grpSpPr>
+      <p:sp>
+        <p:nvSpPr>
+          <p:cNvPr id="2" name="Text 0"/>
+          <p:cNvSpPr/>
+          <p:nvPr>
+            <p:ph idx="100" type="title" hasCustomPrompt="1"/>
+          </p:nvPr>
+        </p:nvSpPr>
+        <p:spPr>
+          <a:xfrm>
+            <a:off x="457200" y="365760"/>
+            <a:ext cx="8686800" cy="685800"/>
+          </a:xfrm>
+          <a:prstGeom prst="rect">
+            <a:avLst/>
+          </a:prstGeom>
+          <a:noFill/>
+          <a:ln/>
+        </p:spPr>
+        <p:txBody>
+          <a:bodyPr wrap="square" lIns="0" tIns="0" rIns="0" bIns="0" rtlCol="0" anchor="ctr"/>
+          <a:lstStyle/>
+          <a:p>
+            <a:pPr algn="l" indent="0" marL="0">
+              <a:buNone/>
+            </a:pPr>
+            <a:r>
+              <a:rPr lang="en-US" sz="3000" b="1" dirty="0">
+                <a:solidFill>
+                  <a:schemeClr val="tx1"/>
+                </a:solidFill>
+              </a:rPr>
+              <a:t>Pruebas de color</a:t>
+            </a:r>
+            <a:endParaRPr lang="en-US" sz="3000" dirty="0"/>
+          </a:p>
+        </p:txBody>
+      </p:sp>
+      <p:sp>
+        <p:nvSpPr>
+          <p:cNvPr id="3" name="Text 0"/>
+          <p:cNvSpPr/>
+          <p:nvPr>
+            <p:ph idx="101" type="body" hasCustomPrompt="1"/>
+          </p:nvPr>
+        </p:nvSpPr>
+        <p:spPr>
+          <a:xfrm>
+            <a:off x="457200" y="1005840"/>
+            <a:ext cx="8686800" cy="365760"/>
+          </a:xfrm>
+          <a:prstGeom prst="rect">
+            <a:avLst/>
+          </a:prstGeom>
+          <a:noFill/>
+          <a:ln/>
+        </p:spPr>
+        <p:txBody>
+          <a:bodyPr wrap="square" lIns="0" tIns="0" rIns="0" bIns="0" rtlCol="0" anchor="t"/>
+          <a:lstStyle/>
+          <a:p>
+            <a:pPr indent="0" marL="0">
+              <a:buNone/>
+            </a:pPr>
+            <a:r>
+              <a:rPr lang="en-US" sz="1200" spc="300" kern="0" dirty="0">
+                <a:solidFill>
+                  <a:schemeClr val="accent6"/>
+                </a:solidFill>
+              </a:rPr>
+              <a:t>SISTEMA · ARAUCARIA DE RAMAS (A2)</a:t>
+            </a:r>
+            <a:endParaRPr lang="en-US" sz="1200" dirty="0"/>
+          </a:p>
+        </p:txBody>
+      </p:sp>
+      <p:sp>
+        <p:nvSpPr>
+          <p:cNvPr id="4" name="Text 0"/>
+          <p:cNvSpPr/>
+          <p:nvPr>
+            <p:ph idx="102" type="body" hasCustomPrompt="1"/>
+          </p:nvPr>
+        </p:nvSpPr>
+        <p:spPr>
+          <a:xfrm>
+            <a:off x="457200" y="1417320"/>
+            <a:ext cx="11247120" cy="777240"/>
+          </a:xfrm>
+          <a:prstGeom prst="rect">
+            <a:avLst/>
+          </a:prstGeom>
+          <a:noFill/>
+          <a:ln/>
+        </p:spPr>
+        <p:txBody>
+          <a:bodyPr wrap="square" lIns="0" tIns="0" rIns="0" bIns="0" rtlCol="0" anchor="t"/>
+          <a:lstStyle/>
+          <a:p>
+            <a:pPr indent="0" marL="0">
+              <a:lnSpc>
+                <a:spcPct val="115000"/>
+              </a:lnSpc>
+              <a:buNone/>
+            </a:pPr>
+            <a:r>
+              <a:rPr lang="en-US" sz="1500" dirty="0">
+                <a:solidFill>
+                  <a:schemeClr val="tx1"/>
+                </a:solidFill>
+              </a:rPr>
+              <a:t>La misma marca en las combinaciones de la paleta: todas funcionan a una o dos tintas y conservan el contraste.</a:t>
+            </a:r>
+            <a:endParaRPr lang="en-US" sz="1500" dirty="0"/>
+          </a:p>
+        </p:txBody>
+      </p:sp>
+      <p:sp>
+        <p:nvSpPr>
+          <p:cNvPr id="5" name="Prueba Verde selva · kraft y crudo"/>
+          <p:cNvSpPr/>
+          <p:nvPr/>
+        </p:nvSpPr>
+        <p:spPr>
+          <a:xfrm>
+            <a:off x="457200" y="2103120"/>
+            <a:ext cx="3611880" cy="1920240"/>
+          </a:xfrm>
+          <a:prstGeom prst="roundRect">
+            <a:avLst>
+              <a:gd name="adj" fmla="val 5714"/>
+            </a:avLst>
+          </a:prstGeom>
+          <a:solidFill>
+            <a:schemeClr val="tx1"/>
+          </a:solidFill>
+          <a:ln w="12700">
+            <a:solidFill>
+              <a:schemeClr val="tx1"/>
+            </a:solidFill>
+            <a:prstDash val="solid"/>
+          </a:ln>
+        </p:spPr>
+      </p:sp>
+      <p:pic>
+        <p:nvPicPr>
+          <p:cNvPr id="6" name="Logo Verde selva · kraft y crudo" descr="Araucaria de ramas · Verde selva · kraft y crudo">    </p:cNvPr>
+          <p:cNvPicPr>
+            <a:picLocks noChangeAspect="1"/>
+          </p:cNvPicPr>
+          <p:nvPr/>
+        </p:nvPicPr>
+        <p:blipFill>
+          <a:blip r:embed="rId1"/>
+          <a:stretch>
+            <a:fillRect/>
+          </a:stretch>
+        </p:blipFill>
+        <p:spPr>
+          <a:xfrm>
+            <a:off x="937260" y="2478425"/>
+            <a:ext cx="2651760" cy="950174"/>
+          </a:xfrm>
+          <a:prstGeom prst="rect">
+            <a:avLst/>
+          </a:prstGeom>
+        </p:spPr>
+      </p:pic>
+      <p:sp>
+        <p:nvSpPr>
+          <p:cNvPr id="7" name="Rótulo"/>
+          <p:cNvSpPr txBox="1"/>
+          <p:nvPr/>
+        </p:nvSpPr>
+        <p:spPr>
+          <a:xfrm>
+            <a:off x="640080" y="3675888"/>
+            <a:ext cx="3291840" cy="228600"/>
+          </a:xfrm>
+          <a:prstGeom prst="rect">
+            <a:avLst/>
+          </a:prstGeom>
+          <a:noFill/>
+          <a:ln/>
+        </p:spPr>
+        <p:txBody>
+          <a:bodyPr wrap="square" lIns="0" tIns="0" rIns="0" bIns="0" rtlCol="0" anchor="ctr"/>
+          <a:lstStyle/>
+          <a:p>
+            <a:pPr indent="0" marL="0">
+              <a:buNone/>
+            </a:pPr>
+            <a:r>
+              <a:rPr lang="en-US" sz="1000" spc="200" kern="0" dirty="0">
+                <a:solidFill>
+                  <a:schemeClr val="accent5"/>
+                </a:solidFill>
+              </a:rPr>
+              <a:t>VERDE SELVA · KRAFT Y CRUDO</a:t>
+            </a:r>
+            <a:endParaRPr lang="en-US" sz="1000" dirty="0"/>
+          </a:p>
+        </p:txBody>
+      </p:sp>
+      <p:sp>
+        <p:nvSpPr>
+          <p:cNvPr id="8" name="Prueba Kraft · verde selva"/>
+          <p:cNvSpPr/>
+          <p:nvPr/>
+        </p:nvSpPr>
+        <p:spPr>
+          <a:xfrm>
+            <a:off x="4251960" y="2103120"/>
+            <a:ext cx="3611880" cy="1920240"/>
+          </a:xfrm>
+          <a:prstGeom prst="roundRect">
+            <a:avLst>
+              <a:gd name="adj" fmla="val 5714"/>
+            </a:avLst>
+          </a:prstGeom>
+          <a:solidFill>
+            <a:schemeClr val="accent1"/>
+          </a:solidFill>
+          <a:ln w="12700">
+            <a:solidFill>
+              <a:schemeClr val="accent1"/>
+            </a:solidFill>
+            <a:prstDash val="solid"/>
+          </a:ln>
+        </p:spPr>
+      </p:sp>
+      <p:pic>
+        <p:nvPicPr>
+          <p:cNvPr id="9" name="Logo Kraft · verde selva" descr="Araucaria de ramas · Kraft · verde selva">    </p:cNvPr>
+          <p:cNvPicPr>
+            <a:picLocks noChangeAspect="1"/>
+          </p:cNvPicPr>
+          <p:nvPr/>
+        </p:nvPicPr>
+        <p:blipFill>
+          <a:blip r:embed="rId2"/>
+          <a:stretch>
+            <a:fillRect/>
+          </a:stretch>
+        </p:blipFill>
+        <p:spPr>
+          <a:xfrm>
+            <a:off x="4732020" y="2478425"/>
+            <a:ext cx="2651760" cy="950174"/>
+          </a:xfrm>
+          <a:prstGeom prst="rect">
+            <a:avLst/>
+          </a:prstGeom>
+        </p:spPr>
+      </p:pic>
+      <p:sp>
+        <p:nvSpPr>
+          <p:cNvPr id="10" name="Rótulo"/>
+          <p:cNvSpPr txBox="1"/>
+          <p:nvPr/>
+        </p:nvSpPr>
+        <p:spPr>
+          <a:xfrm>
+            <a:off x="4434840" y="3675888"/>
+            <a:ext cx="3291840" cy="228600"/>
+          </a:xfrm>
+          <a:prstGeom prst="rect">
+            <a:avLst/>
+          </a:prstGeom>
+          <a:noFill/>
+          <a:ln/>
+        </p:spPr>
+        <p:txBody>
+          <a:bodyPr wrap="square" lIns="0" tIns="0" rIns="0" bIns="0" rtlCol="0" anchor="ctr"/>
+          <a:lstStyle/>
+          <a:p>
+            <a:pPr indent="0" marL="0">
+              <a:buNone/>
+            </a:pPr>
+            <a:r>
+              <a:rPr lang="en-US" sz="1000" spc="200" kern="0" dirty="0">
+                <a:solidFill>
+                  <a:schemeClr val="tx2"/>
+                </a:solidFill>
+              </a:rPr>
+              <a:t>KRAFT · VERDE SELVA</a:t>
+            </a:r>
+            <a:endParaRPr lang="en-US" sz="1000" dirty="0"/>
+          </a:p>
+        </p:txBody>
+      </p:sp>
+      <p:sp>
+        <p:nvSpPr>
+          <p:cNvPr id="11" name="Prueba Papel crudo · verde selva"/>
+          <p:cNvSpPr/>
+          <p:nvPr/>
+        </p:nvSpPr>
+        <p:spPr>
+          <a:xfrm>
+            <a:off x="8046720" y="2103120"/>
+            <a:ext cx="3611880" cy="1920240"/>
+          </a:xfrm>
+          <a:prstGeom prst="roundRect">
+            <a:avLst>
+              <a:gd name="adj" fmla="val 5714"/>
+            </a:avLst>
+          </a:prstGeom>
+          <a:solidFill>
+            <a:schemeClr val="bg2"/>
+          </a:solidFill>
+          <a:ln w="12700">
+            <a:solidFill>
+              <a:schemeClr val="accent5"/>
+            </a:solidFill>
+            <a:prstDash val="solid"/>
+          </a:ln>
+        </p:spPr>
+      </p:sp>
+      <p:pic>
+        <p:nvPicPr>
+          <p:cNvPr id="12" name="Logo Papel crudo · verde selva" descr="Araucaria de ramas · Papel crudo · verde selva">    </p:cNvPr>
+          <p:cNvPicPr>
+            <a:picLocks noChangeAspect="1"/>
+          </p:cNvPicPr>
+          <p:nvPr/>
+        </p:nvPicPr>
+        <p:blipFill>
+          <a:blip r:embed="rId3"/>
+          <a:stretch>
+            <a:fillRect/>
+          </a:stretch>
+        </p:blipFill>
+        <p:spPr>
+          <a:xfrm>
+            <a:off x="8526780" y="2478425"/>
+            <a:ext cx="2651760" cy="950174"/>
+          </a:xfrm>
+          <a:prstGeom prst="rect">
+            <a:avLst/>
+          </a:prstGeom>
+        </p:spPr>
+      </p:pic>
+      <p:sp>
+        <p:nvSpPr>
+          <p:cNvPr id="13" name="Rótulo"/>
+          <p:cNvSpPr txBox="1"/>
+          <p:nvPr/>
+        </p:nvSpPr>
+        <p:spPr>
+          <a:xfrm>
+            <a:off x="8229600" y="3675888"/>
+            <a:ext cx="3291840" cy="228600"/>
+          </a:xfrm>
+          <a:prstGeom prst="rect">
+            <a:avLst/>
+          </a:prstGeom>
+          <a:noFill/>
+          <a:ln/>
+        </p:spPr>
+        <p:txBody>
+          <a:bodyPr wrap="square" lIns="0" tIns="0" rIns="0" bIns="0" rtlCol="0" anchor="ctr"/>
+          <a:lstStyle/>
+          <a:p>
+            <a:pPr indent="0" marL="0">
+              <a:buNone/>
+            </a:pPr>
+            <a:r>
+              <a:rPr lang="en-US" sz="1000" spc="200" kern="0" dirty="0">
+                <a:solidFill>
+                  <a:schemeClr val="accent6"/>
+                </a:solidFill>
+              </a:rPr>
+              <a:t>PAPEL CRUDO · VERDE SELVA</a:t>
+            </a:r>
+            <a:endParaRPr lang="en-US" sz="1000" dirty="0"/>
+          </a:p>
+        </p:txBody>
+      </p:sp>
+      <p:sp>
+        <p:nvSpPr>
+          <p:cNvPr id="14" name="Prueba Tierra colorada · crudo"/>
+          <p:cNvSpPr/>
+          <p:nvPr/>
+        </p:nvSpPr>
+        <p:spPr>
+          <a:xfrm>
+            <a:off x="457200" y="4206240"/>
+            <a:ext cx="3611880" cy="1920240"/>
+          </a:xfrm>
+          <a:prstGeom prst="roundRect">
+            <a:avLst>
+              <a:gd name="adj" fmla="val 5714"/>
+            </a:avLst>
+          </a:prstGeom>
+          <a:solidFill>
+            <a:schemeClr val="accent2"/>
+          </a:solidFill>
+          <a:ln w="12700">
+            <a:solidFill>
+              <a:schemeClr val="accent2"/>
+            </a:solidFill>
+            <a:prstDash val="solid"/>
+          </a:ln>
+        </p:spPr>
+      </p:sp>
+      <p:pic>
+        <p:nvPicPr>
+          <p:cNvPr id="15" name="Logo Tierra colorada · crudo" descr="Araucaria de ramas · Tierra colorada · crudo">    </p:cNvPr>
+          <p:cNvPicPr>
+            <a:picLocks noChangeAspect="1"/>
+          </p:cNvPicPr>
+          <p:nvPr/>
+        </p:nvPicPr>
+        <p:blipFill>
+          <a:blip r:embed="rId4"/>
+          <a:stretch>
+            <a:fillRect/>
+          </a:stretch>
+        </p:blipFill>
+        <p:spPr>
+          <a:xfrm>
+            <a:off x="937260" y="4581545"/>
+            <a:ext cx="2651760" cy="950174"/>
+          </a:xfrm>
+          <a:prstGeom prst="rect">
+            <a:avLst/>
+          </a:prstGeom>
+        </p:spPr>
+      </p:pic>
+      <p:sp>
+        <p:nvSpPr>
+          <p:cNvPr id="16" name="Rótulo"/>
+          <p:cNvSpPr txBox="1"/>
+          <p:nvPr/>
+        </p:nvSpPr>
+        <p:spPr>
+          <a:xfrm>
+            <a:off x="640080" y="5779008"/>
+            <a:ext cx="3291840" cy="228600"/>
+          </a:xfrm>
+          <a:prstGeom prst="rect">
+            <a:avLst/>
+          </a:prstGeom>
+          <a:noFill/>
+          <a:ln/>
+        </p:spPr>
+        <p:txBody>
+          <a:bodyPr wrap="square" lIns="0" tIns="0" rIns="0" bIns="0" rtlCol="0" anchor="ctr"/>
+          <a:lstStyle/>
+          <a:p>
+            <a:pPr indent="0" marL="0">
+              <a:buNone/>
+            </a:pPr>
+            <a:r>
+              <a:rPr lang="en-US" sz="1000" spc="200" kern="0" dirty="0">
+                <a:solidFill>
+                  <a:schemeClr val="bg2"/>
+                </a:solidFill>
+              </a:rPr>
+              <a:t>TIERRA COLORADA · CRUDO</a:t>
+            </a:r>
+            <a:endParaRPr lang="en-US" sz="1000" dirty="0"/>
+          </a:p>
+        </p:txBody>
+      </p:sp>
+      <p:sp>
+        <p:nvSpPr>
+          <p:cNvPr id="17" name="Prueba Kraft oscuro · crudo"/>
+          <p:cNvSpPr/>
+          <p:nvPr/>
+        </p:nvSpPr>
+        <p:spPr>
+          <a:xfrm>
+            <a:off x="4251960" y="4206240"/>
+            <a:ext cx="3611880" cy="1920240"/>
+          </a:xfrm>
+          <a:prstGeom prst="roundRect">
+            <a:avLst>
+              <a:gd name="adj" fmla="val 5714"/>
+            </a:avLst>
+          </a:prstGeom>
+          <a:solidFill>
+            <a:schemeClr val="accent3"/>
+          </a:solidFill>
+          <a:ln w="12700">
+            <a:solidFill>
+              <a:schemeClr val="accent3"/>
+            </a:solidFill>
+            <a:prstDash val="solid"/>
+          </a:ln>
+        </p:spPr>
+      </p:sp>
+      <p:pic>
+        <p:nvPicPr>
+          <p:cNvPr id="18" name="Logo Kraft oscuro · crudo" descr="Araucaria de ramas · Kraft oscuro · crudo">    </p:cNvPr>
+          <p:cNvPicPr>
+            <a:picLocks noChangeAspect="1"/>
+          </p:cNvPicPr>
+          <p:nvPr/>
+        </p:nvPicPr>
+        <p:blipFill>
+          <a:blip r:embed="rId5"/>
+          <a:stretch>
+            <a:fillRect/>
+          </a:stretch>
+        </p:blipFill>
+        <p:spPr>
+          <a:xfrm>
+            <a:off x="4732020" y="4581545"/>
+            <a:ext cx="2651760" cy="950174"/>
+          </a:xfrm>
+          <a:prstGeom prst="rect">
+            <a:avLst/>
+          </a:prstGeom>
+        </p:spPr>
+      </p:pic>
+      <p:sp>
+        <p:nvSpPr>
+          <p:cNvPr id="19" name="Rótulo"/>
+          <p:cNvSpPr txBox="1"/>
+          <p:nvPr/>
+        </p:nvSpPr>
+        <p:spPr>
+          <a:xfrm>
+            <a:off x="4434840" y="5779008"/>
+            <a:ext cx="3291840" cy="228600"/>
+          </a:xfrm>
+          <a:prstGeom prst="rect">
+            <a:avLst/>
+          </a:prstGeom>
+          <a:noFill/>
+          <a:ln/>
+        </p:spPr>
+        <p:txBody>
+          <a:bodyPr wrap="square" lIns="0" tIns="0" rIns="0" bIns="0" rtlCol="0" anchor="ctr"/>
+          <a:lstStyle/>
+          <a:p>
+            <a:pPr indent="0" marL="0">
+              <a:buNone/>
+            </a:pPr>
+            <a:r>
+              <a:rPr lang="en-US" sz="1000" spc="200" kern="0" dirty="0">
+                <a:solidFill>
+                  <a:schemeClr val="bg2"/>
+                </a:solidFill>
+              </a:rPr>
+              <a:t>KRAFT OSCURO · CRUDO</a:t>
+            </a:r>
+            <a:endParaRPr lang="en-US" sz="1000" dirty="0"/>
+          </a:p>
+        </p:txBody>
+      </p:sp>
+      <p:sp>
+        <p:nvSpPr>
+          <p:cNvPr id="20" name="Prueba Papel crudo · tierra y verde"/>
+          <p:cNvSpPr/>
+          <p:nvPr/>
+        </p:nvSpPr>
+        <p:spPr>
+          <a:xfrm>
+            <a:off x="8046720" y="4206240"/>
+            <a:ext cx="3611880" cy="1920240"/>
+          </a:xfrm>
+          <a:prstGeom prst="roundRect">
+            <a:avLst>
+              <a:gd name="adj" fmla="val 5714"/>
+            </a:avLst>
+          </a:prstGeom>
+          <a:solidFill>
+            <a:schemeClr val="bg2"/>
+          </a:solidFill>
+          <a:ln w="12700">
+            <a:solidFill>
+              <a:schemeClr val="accent5"/>
+            </a:solidFill>
+            <a:prstDash val="solid"/>
+          </a:ln>
+        </p:spPr>
+      </p:sp>
+      <p:pic>
+        <p:nvPicPr>
+          <p:cNvPr id="21" name="Logo Papel crudo · tierra y verde" descr="Araucaria de ramas · Papel crudo · tierra y verde">    </p:cNvPr>
+          <p:cNvPicPr>
+            <a:picLocks noChangeAspect="1"/>
+          </p:cNvPicPr>
+          <p:nvPr/>
+        </p:nvPicPr>
+        <p:blipFill>
+          <a:blip r:embed="rId6"/>
+          <a:stretch>
+            <a:fillRect/>
+          </a:stretch>
+        </p:blipFill>
+        <p:spPr>
+          <a:xfrm>
+            <a:off x="8526780" y="4581545"/>
+            <a:ext cx="2651760" cy="950174"/>
+          </a:xfrm>
+          <a:prstGeom prst="rect">
+            <a:avLst/>
+          </a:prstGeom>
+        </p:spPr>
+      </p:pic>
+      <p:sp>
+        <p:nvSpPr>
+          <p:cNvPr id="22" name="Rótulo"/>
+          <p:cNvSpPr txBox="1"/>
+          <p:nvPr/>
+        </p:nvSpPr>
+        <p:spPr>
+          <a:xfrm>
+            <a:off x="8229600" y="5779008"/>
+            <a:ext cx="3291840" cy="228600"/>
+          </a:xfrm>
+          <a:prstGeom prst="rect">
+            <a:avLst/>
+          </a:prstGeom>
+          <a:noFill/>
+          <a:ln/>
+        </p:spPr>
+        <p:txBody>
+          <a:bodyPr wrap="square" lIns="0" tIns="0" rIns="0" bIns="0" rtlCol="0" anchor="ctr"/>
+          <a:lstStyle/>
+          <a:p>
+            <a:pPr indent="0" marL="0">
+              <a:buNone/>
+            </a:pPr>
+            <a:r>
+              <a:rPr lang="en-US" sz="1000" spc="200" kern="0" dirty="0">
+                <a:solidFill>
+                  <a:schemeClr val="accent6"/>
+                </a:solidFill>
+              </a:rPr>
+              <a:t>PAPEL CRUDO · TIERRA Y VERDE</a:t>
+            </a:r>
+            <a:endParaRPr lang="en-US" sz="1000" dirty="0"/>
+          </a:p>
+        </p:txBody>
+      </p:sp>
+      <p:sp>
+        <p:nvSpPr>
+          <p:cNvPr id="25" name="Slide Number Placeholder 0"/>
+          <p:cNvSpPr>
+            <a:spLocks noGrp="1"/>
+          </p:cNvSpPr>
+          <p:nvPr>
+            <p:ph type="sldNum" sz="quarter" idx="4294967295"/>
+          </p:nvPr>
+        </p:nvSpPr>
+        <p:spPr>
+          <a:xfrm>
+            <a:off x="11247120" y="6400800"/>
+            <a:ext cx="502920" cy="274320"/>
+          </a:xfrm>
+          <a:prstGeom prst="rect">
+            <a:avLst/>
+          </a:prstGeom>
+          <a:extLst>
+            <a:ext uri="{C572A759-6A51-4108-AA02-DFA0A04FC94B}">
+              <ma14:wrappingTextBoxFlag xmlns:ma14="http://schemas.microsoft.com/office/mac/drawingml/2011/main" val="0"/>
+            </a:ext>
+          </a:extLst>
+        </p:spPr>
+        <p:txBody>
+          <a:bodyPr/>
+          <a:lstStyle>
+            <a:lvl1pPr>
+              <a:defRPr sz="1000">
+                <a:solidFill>
+                  <a:schemeClr val="accent6"/>
+                </a:solidFill>
+              </a:defRPr>
+            </a:lvl1pPr>
+          </a:lstStyle>
+          <a:p>
+            <a:pPr algn="r"/>
+            <a:fld id="{F7021451-1387-4CA6-816F-3879F97B5CBC}" type="slidenum">
+              <a:rPr b="0" lang="en-US"/>
+              <a:t>24</a:t>
             </a:fld>
             <a:endParaRPr lang="en-US"/>
           </a:p>
@@ -9465,8 +11401,8 @@
         </p:blipFill>
         <p:spPr>
           <a:xfrm>
-            <a:off x="1348740" y="3473780"/>
-            <a:ext cx="3749040" cy="1373480"/>
+            <a:off x="1348740" y="3488846"/>
+            <a:ext cx="3749040" cy="1343349"/>
           </a:xfrm>
           <a:prstGeom prst="rect">
             <a:avLst/>
@@ -9552,8 +11488,8 @@
         </p:blipFill>
         <p:spPr>
           <a:xfrm>
-            <a:off x="7091172" y="3473780"/>
-            <a:ext cx="3749040" cy="1373480"/>
+            <a:off x="7091172" y="3488846"/>
+            <a:ext cx="3749040" cy="1343349"/>
           </a:xfrm>
           <a:prstGeom prst="rect">
             <a:avLst/>
@@ -9826,8 +11762,8 @@
         </p:blipFill>
         <p:spPr>
           <a:xfrm>
-            <a:off x="1348740" y="3473780"/>
-            <a:ext cx="3749040" cy="1373480"/>
+            <a:off x="1348740" y="3488846"/>
+            <a:ext cx="3749040" cy="1343349"/>
           </a:xfrm>
           <a:prstGeom prst="rect">
             <a:avLst/>
@@ -9913,8 +11849,8 @@
         </p:blipFill>
         <p:spPr>
           <a:xfrm>
-            <a:off x="7091172" y="3473780"/>
-            <a:ext cx="3749040" cy="1373480"/>
+            <a:off x="7091172" y="3488846"/>
+            <a:ext cx="3749040" cy="1343349"/>
           </a:xfrm>
           <a:prstGeom prst="rect">
             <a:avLst/>
@@ -10187,8 +12123,8 @@
         </p:blipFill>
         <p:spPr>
           <a:xfrm>
-            <a:off x="1348740" y="3473780"/>
-            <a:ext cx="3749040" cy="1373480"/>
+            <a:off x="1348740" y="3488846"/>
+            <a:ext cx="3749040" cy="1343349"/>
           </a:xfrm>
           <a:prstGeom prst="rect">
             <a:avLst/>
@@ -10274,8 +12210,8 @@
         </p:blipFill>
         <p:spPr>
           <a:xfrm>
-            <a:off x="7091172" y="3473780"/>
-            <a:ext cx="3749040" cy="1373480"/>
+            <a:off x="7091172" y="3488846"/>
+            <a:ext cx="3749040" cy="1343349"/>
           </a:xfrm>
           <a:prstGeom prst="rect">
             <a:avLst/>
@@ -10548,8 +12484,8 @@
         </p:blipFill>
         <p:spPr>
           <a:xfrm>
-            <a:off x="1348740" y="3473780"/>
-            <a:ext cx="3749040" cy="1373480"/>
+            <a:off x="1348740" y="3488846"/>
+            <a:ext cx="3749040" cy="1343349"/>
           </a:xfrm>
           <a:prstGeom prst="rect">
             <a:avLst/>
@@ -10635,8 +12571,8 @@
         </p:blipFill>
         <p:spPr>
           <a:xfrm>
-            <a:off x="7091172" y="3473780"/>
-            <a:ext cx="3749040" cy="1373480"/>
+            <a:off x="7091172" y="3488846"/>
+            <a:ext cx="3749040" cy="1343349"/>
           </a:xfrm>
           <a:prstGeom prst="rect">
             <a:avLst/>

</xml_diff>